<commit_message>
Module 2: lottery example on the MA article numbers; practice deck gains poll + solution slides
The In-Class lottery example (slides 39/41) switches from the NY
academic figures (1.9M -> 560K, E ~ -0.47) to the Massachusetts
figures from the WROR/WBZ article, rounded per Nico (about 142,000 ->
about 100,000, E ~ -0.20); merged deck rebuilt. The practice deck
gains a poll placeholder and the revenue solution slide after his
'Lottery Sales, Revisited' (new _add_practice_lottery.py pass), its
slide-4 page number becomes a live field, and the article's
non-reconciling dollar figures are documented in the speaker notes.

Co-Authored-By: Claude Fable 5 <noreply@anthropic.com>
</commit_message>
<xml_diff>
--- a/405 Slide Revisions 2026/Module 2/Module 2 - Potential Practice Exercises.pptx
+++ b/405 Slide Revisions 2026/Module 2/Module 2 - Potential Practice Exercises.pptx
@@ -11,7 +11,9 @@
     <p:sldId id="301" r:id="rId2"/>
     <p:sldId id="302" r:id="rId3"/>
     <p:sldId id="303" r:id="rId4"/>
-    <p:sldId id="304" r:id="rId5"/>
+    <p:sldId id="274" r:id="rId5"/>
+    <p:sldId id="307" r:id="rId13"/>
+    <p:sldId id="308" r:id="rId14"/>
     <p:sldId id="305" r:id="rId6"/>
     <p:sldId id="306" r:id="rId7"/>
   </p:sldIdLst>
@@ -213,7 +215,7 @@
           <a:p>
             <a:fld id="{42E1662A-056B-438C-BC34-BD17DCCD74BB}" type="datetimeFigureOut">
               <a:rPr lang="en-US" smtClean="0"/>
-              <a:t>8/25/2026</a:t>
+              <a:t>9/20/2026</a:t>
             </a:fld>
             <a:endParaRPr lang="en-US"/>
           </a:p>
@@ -504,7 +506,7 @@
             <a:spLocks noGrp="1" noRot="1" noChangeAspect="1"/>
           </p:cNvSpPr>
           <p:nvPr>
-            <p:ph type="sldImg" idx="2"/>
+            <p:ph type="sldImg"/>
           </p:nvPr>
         </p:nvSpPr>
         <p:spPr/>
@@ -516,7 +518,7 @@
             <a:spLocks noGrp="1"/>
           </p:cNvSpPr>
           <p:nvPr>
-            <p:ph type="body" sz="quarter" idx="3"/>
+            <p:ph type="body" idx="1"/>
           </p:nvPr>
         </p:nvSpPr>
         <p:spPr/>
@@ -524,9 +526,7 @@
           <a:bodyPr/>
           <a:lstStyle/>
           <a:p>
-            <a:r>
-              <a:t>Back to Mega Millions. Method 1 gave us an elasticity of about −0.47 — inelastic — which suggests the price increase should raise revenue. In fact, revenue per drawing FELL from roughly $3.8 million to $2.8 million. The catch: the price rose 150%, and Method 1 is a small-change approximation. With changes this large, the initial-point elasticity and the revenue rule based on it can point the wrong way — a good reason to be careful before applying the rule to big price moves.</a:t>
-            </a:r>
+            <a:endParaRPr lang="en-US" dirty="0"/>
           </a:p>
         </p:txBody>
       </p:sp>
@@ -538,6 +538,98 @@
           </p:cNvSpPr>
           <p:nvPr>
             <p:ph type="sldNum" sz="quarter" idx="5"/>
+          </p:nvPr>
+        </p:nvSpPr>
+        <p:spPr/>
+        <p:txBody>
+          <a:bodyPr/>
+          <a:lstStyle/>
+          <a:p>
+            <a:fld id="{26C52B9C-F38A-4A42-906A-2292BE291546}" type="slidenum">
+              <a:rPr lang="en-US" smtClean="0"/>
+              <a:t>4</a:t>
+            </a:fld>
+            <a:endParaRPr lang="en-US"/>
+          </a:p>
+        </p:txBody>
+      </p:sp>
+    </p:spTree>
+    <p:extLst>
+      <p:ext uri="{BB962C8B-B14F-4D97-AF65-F5344CB8AC3E}">
+        <p14:creationId xmlns:p14="http://schemas.microsoft.com/office/powerpoint/2010/main" val="1669811220"/>
+      </p:ext>
+    </p:extLst>
+  </p:cSld>
+  <p:clrMapOvr>
+    <a:masterClrMapping/>
+  </p:clrMapOvr>
+</p:notes>
+</file>
+
+<file path=ppt/notesSlides/notesSlide8.xml><?xml version="1.0" encoding="utf-8"?>
+<p:notes xmlns:a="http://schemas.openxmlformats.org/drawingml/2006/main" xmlns:p="http://schemas.openxmlformats.org/presentationml/2006/main" xmlns:r="http://schemas.openxmlformats.org/officeDocument/2006/relationships">
+  <p:cSld>
+    <p:spTree>
+      <p:nvGrpSpPr>
+        <p:cNvPr id="1" name=""/>
+        <p:cNvGrpSpPr/>
+        <p:nvPr/>
+      </p:nvGrpSpPr>
+      <p:grpSpPr>
+        <a:xfrm>
+          <a:off x="0" y="0"/>
+          <a:ext cx="0" cy="0"/>
+          <a:chOff x="0" y="0"/>
+          <a:chExt cx="0" cy="0"/>
+        </a:xfrm>
+      </p:grpSpPr>
+      <p:sp>
+        <p:nvSpPr>
+          <p:cNvPr id="2" name="Slide Image Placeholder 1"/>
+          <p:cNvSpPr>
+            <a:spLocks noGrp="1"/>
+          </p:cNvSpPr>
+          <p:nvPr>
+            <p:ph type="sldImg" idx="2"/>
+          </p:nvPr>
+        </p:nvSpPr>
+        <p:spPr/>
+      </p:sp>
+      <p:sp>
+        <p:nvSpPr>
+          <p:cNvPr id="3" name="Notes Placeholder 2"/>
+          <p:cNvSpPr>
+            <a:spLocks noGrp="1"/>
+          </p:cNvSpPr>
+          <p:nvPr>
+            <p:ph type="body" idx="3" sz="quarter"/>
+          </p:nvPr>
+        </p:nvSpPr>
+        <p:spPr/>
+        <p:txBody>
+          <a:bodyPr/>
+          <a:lstStyle/>
+          <a:p>
+            <a:r>
+              <a:t>With an elasticity of about −0.2, demand is well inside the inelastic range, so the 150% price increase outweighs the roughly 30% drop in tickets and revenue rises. From the rounded ticket counts: 142,000 tickets at $2 is $284,000; 100,000 tickets at $5 is $500,000 - up about 76%. Multiplicative check: 2.50 × 0.704 ≈ 1.76.</a:t>
+            </a:r>
+          </a:p>
+          <a:p/>
+          <a:p>
+            <a:r>
+              <a:t>Caution (kept off the slide): the article's own dollar figures ($491,323 → $841,185, “+71%”) do not equal tickets × price (they imply $3.46 and $8.39 per ticket), so they must cover more than the base ticket sales counted here; the revenue check above uses the reported ticket counts (142,170 and 100,297, rounded), and the qualitative conclusion is unchanged. Source: WROR / BostonNewsroom, April 10, 2025, citing the Massachusetts Lottery (WBZ-TV).</a:t>
+            </a:r>
+          </a:p>
+        </p:txBody>
+      </p:sp>
+      <p:sp>
+        <p:nvSpPr>
+          <p:cNvPr id="4" name="Slide Number Placeholder 3"/>
+          <p:cNvSpPr>
+            <a:spLocks noGrp="1"/>
+          </p:cNvSpPr>
+          <p:nvPr>
+            <p:ph type="sldNum" idx="5" sz="quarter"/>
           </p:nvPr>
         </p:nvSpPr>
         <p:spPr/>
@@ -729,7 +821,7 @@
           <a:p>
             <a:fld id="{5BCAD085-E8A6-8845-BD4E-CB4CCA059FC4}" type="datetimeFigureOut">
               <a:rPr lang="en-US" smtClean="0"/>
-              <a:t>8/25/2026</a:t>
+              <a:t>9/20/2026</a:t>
             </a:fld>
             <a:endParaRPr lang="en-US"/>
           </a:p>
@@ -897,7 +989,7 @@
           <a:p>
             <a:fld id="{5BCAD085-E8A6-8845-BD4E-CB4CCA059FC4}" type="datetimeFigureOut">
               <a:rPr lang="en-US" smtClean="0"/>
-              <a:t>8/25/2026</a:t>
+              <a:t>9/20/2026</a:t>
             </a:fld>
             <a:endParaRPr lang="en-US"/>
           </a:p>
@@ -1075,7 +1167,7 @@
           <a:p>
             <a:fld id="{5BCAD085-E8A6-8845-BD4E-CB4CCA059FC4}" type="datetimeFigureOut">
               <a:rPr lang="en-US" smtClean="0"/>
-              <a:t>8/25/2026</a:t>
+              <a:t>9/20/2026</a:t>
             </a:fld>
             <a:endParaRPr lang="en-US"/>
           </a:p>
@@ -1243,7 +1335,7 @@
           <a:p>
             <a:fld id="{5BCAD085-E8A6-8845-BD4E-CB4CCA059FC4}" type="datetimeFigureOut">
               <a:rPr lang="en-US" smtClean="0"/>
-              <a:t>8/25/2026</a:t>
+              <a:t>9/20/2026</a:t>
             </a:fld>
             <a:endParaRPr lang="en-US"/>
           </a:p>
@@ -1488,7 +1580,7 @@
           <a:p>
             <a:fld id="{5BCAD085-E8A6-8845-BD4E-CB4CCA059FC4}" type="datetimeFigureOut">
               <a:rPr lang="en-US" smtClean="0"/>
-              <a:t>8/25/2026</a:t>
+              <a:t>9/20/2026</a:t>
             </a:fld>
             <a:endParaRPr lang="en-US"/>
           </a:p>
@@ -1773,7 +1865,7 @@
           <a:p>
             <a:fld id="{5BCAD085-E8A6-8845-BD4E-CB4CCA059FC4}" type="datetimeFigureOut">
               <a:rPr lang="en-US" smtClean="0"/>
-              <a:t>8/25/2026</a:t>
+              <a:t>9/20/2026</a:t>
             </a:fld>
             <a:endParaRPr lang="en-US"/>
           </a:p>
@@ -2192,7 +2284,7 @@
           <a:p>
             <a:fld id="{5BCAD085-E8A6-8845-BD4E-CB4CCA059FC4}" type="datetimeFigureOut">
               <a:rPr lang="en-US" smtClean="0"/>
-              <a:t>8/25/2026</a:t>
+              <a:t>9/20/2026</a:t>
             </a:fld>
             <a:endParaRPr lang="en-US"/>
           </a:p>
@@ -2309,7 +2401,7 @@
           <a:p>
             <a:fld id="{5BCAD085-E8A6-8845-BD4E-CB4CCA059FC4}" type="datetimeFigureOut">
               <a:rPr lang="en-US" smtClean="0"/>
-              <a:t>8/25/2026</a:t>
+              <a:t>9/20/2026</a:t>
             </a:fld>
             <a:endParaRPr lang="en-US"/>
           </a:p>
@@ -2404,7 +2496,7 @@
           <a:p>
             <a:fld id="{5BCAD085-E8A6-8845-BD4E-CB4CCA059FC4}" type="datetimeFigureOut">
               <a:rPr lang="en-US" smtClean="0"/>
-              <a:t>8/25/2026</a:t>
+              <a:t>9/20/2026</a:t>
             </a:fld>
             <a:endParaRPr lang="en-US"/>
           </a:p>
@@ -2679,7 +2771,7 @@
           <a:p>
             <a:fld id="{5BCAD085-E8A6-8845-BD4E-CB4CCA059FC4}" type="datetimeFigureOut">
               <a:rPr lang="en-US" smtClean="0"/>
-              <a:t>8/25/2026</a:t>
+              <a:t>9/20/2026</a:t>
             </a:fld>
             <a:endParaRPr lang="en-US"/>
           </a:p>
@@ -2931,7 +3023,7 @@
           <a:p>
             <a:fld id="{5BCAD085-E8A6-8845-BD4E-CB4CCA059FC4}" type="datetimeFigureOut">
               <a:rPr lang="en-US" smtClean="0"/>
-              <a:t>8/25/2026</a:t>
+              <a:t>9/20/2026</a:t>
             </a:fld>
             <a:endParaRPr lang="en-US"/>
           </a:p>
@@ -3142,7 +3234,7 @@
           <a:p>
             <a:fld id="{5BCAD085-E8A6-8845-BD4E-CB4CCA059FC4}" type="datetimeFigureOut">
               <a:rPr lang="en-US" smtClean="0"/>
-              <a:t>8/25/2026</a:t>
+              <a:t>9/20/2026</a:t>
             </a:fld>
             <a:endParaRPr lang="en-US"/>
           </a:p>
@@ -5986,9 +6078,37 @@
           <a:chExt cx="0" cy="0"/>
         </a:xfrm>
       </p:grpSpPr>
-      <p:sp>
-        <p:nvSpPr>
-          <p:cNvPr id="2" name="Rectangle 1"/>
+      <p:pic>
+        <p:nvPicPr>
+          <p:cNvPr id="2" name="Picture 1" descr="image21.png"/>
+          <p:cNvPicPr>
+            <a:picLocks noChangeAspect="1"/>
+          </p:cNvPicPr>
+          <p:nvPr/>
+        </p:nvPicPr>
+        <p:blipFill>
+          <a:blip r:embed="rId3">
+            <a:alphaModFix amt="16000"/>
+            <a:lum/>
+          </a:blip>
+          <a:stretch>
+            <a:fillRect/>
+          </a:stretch>
+        </p:blipFill>
+        <p:spPr>
+          <a:xfrm>
+            <a:off x="0" y="0"/>
+            <a:ext cx="12191695" cy="6858000"/>
+          </a:xfrm>
+          <a:prstGeom prst="rect">
+            <a:avLst/>
+          </a:prstGeom>
+          <a:effectLst/>
+        </p:spPr>
+      </p:pic>
+      <p:sp>
+        <p:nvSpPr>
+          <p:cNvPr id="3" name="Rectangle 2"/>
           <p:cNvSpPr/>
           <p:nvPr/>
         </p:nvSpPr>
@@ -6033,14 +6153,14 @@
       </p:sp>
       <p:sp>
         <p:nvSpPr>
-          <p:cNvPr id="3" name="TextBox 2"/>
+          <p:cNvPr id="4" name="TextBox 3"/>
           <p:cNvSpPr txBox="1"/>
           <p:nvPr/>
         </p:nvSpPr>
         <p:spPr>
           <a:xfrm>
-            <a:off x="251999" y="0"/>
-            <a:ext cx="10972800" cy="384048"/>
+            <a:off x="274320" y="18288"/>
+            <a:ext cx="10972800" cy="365760"/>
           </a:xfrm>
           <a:prstGeom prst="rect">
             <a:avLst/>
@@ -6053,29 +6173,36 @@
           </a:bodyPr>
           <a:lstStyle/>
           <a:p>
-            <a:pPr algn="l"/>
-            <a:r>
-              <a:rPr sz="1600" b="1" i="0" u="none">
+            <a:pPr algn="l">
+              <a:spcBef>
+                <a:spcPts val="0"/>
+              </a:spcBef>
+              <a:spcAft>
+                <a:spcPts val="200"/>
+              </a:spcAft>
+            </a:pPr>
+            <a:r>
+              <a:rPr sz="1500" b="1" i="0">
                 <a:solidFill>
                   <a:srgbClr val="FFFFFF"/>
                 </a:solidFill>
                 <a:latin typeface="Calibri"/>
               </a:rPr>
-              <a:t>Module 2 · Video 1 · Demand and Revenue</a:t>
-            </a:r>
-          </a:p>
-        </p:txBody>
-      </p:sp>
-      <p:sp>
-        <p:nvSpPr>
-          <p:cNvPr id="4" name="TextBox 3"/>
+              <a:t>Demand Analysis · Elasticity and Revenue</a:t>
+            </a:r>
+          </a:p>
+        </p:txBody>
+      </p:sp>
+      <p:sp>
+        <p:nvSpPr>
+          <p:cNvPr id="5" name="TextBox 4"/>
           <p:cNvSpPr txBox="1"/>
           <p:nvPr/>
         </p:nvSpPr>
         <p:spPr>
           <a:xfrm>
-            <a:off x="251999" y="502920"/>
-            <a:ext cx="11687697" cy="640080"/>
+            <a:off x="274320" y="502920"/>
+            <a:ext cx="11640312" cy="713232"/>
           </a:xfrm>
           <a:prstGeom prst="rect">
             <a:avLst/>
@@ -6083,34 +6210,41 @@
           <a:noFill/>
         </p:spPr>
         <p:txBody>
-          <a:bodyPr wrap="square" lIns="0" tIns="0" rIns="0" bIns="0">
+          <a:bodyPr wrap="square" lIns="0" tIns="0" rIns="0" bIns="0" anchor="ctr">
             <a:spAutoFit/>
           </a:bodyPr>
           <a:lstStyle/>
           <a:p>
-            <a:pPr algn="l"/>
-            <a:r>
-              <a:rPr sz="3200" b="1" i="0" u="none">
+            <a:pPr algn="l">
+              <a:spcBef>
+                <a:spcPts val="0"/>
+              </a:spcBef>
+              <a:spcAft>
+                <a:spcPts val="200"/>
+              </a:spcAft>
+            </a:pPr>
+            <a:r>
+              <a:rPr sz="3000" b="1" i="0" dirty="0">
                 <a:solidFill>
                   <a:srgbClr val="0B2B4E"/>
                 </a:solidFill>
                 <a:latin typeface="Calibri"/>
               </a:rPr>
-              <a:t>Mega Millions, Revisited</a:t>
-            </a:r>
-          </a:p>
-        </p:txBody>
-      </p:sp>
-      <p:sp>
-        <p:nvSpPr>
-          <p:cNvPr id="5" name="Rectangle 4"/>
+              <a:t>Lottery Sales, Revisited</a:t>
+            </a:r>
+          </a:p>
+        </p:txBody>
+      </p:sp>
+      <p:sp>
+        <p:nvSpPr>
+          <p:cNvPr id="6" name="Rectangle 5"/>
           <p:cNvSpPr/>
           <p:nvPr/>
         </p:nvSpPr>
         <p:spPr>
           <a:xfrm>
-            <a:off x="251999" y="1143000"/>
-            <a:ext cx="11687697" cy="18288"/>
+            <a:off x="274320" y="1170432"/>
+            <a:ext cx="11640312" cy="18288"/>
           </a:xfrm>
           <a:prstGeom prst="rect">
             <a:avLst/>
@@ -6148,13 +6282,13 @@
       </p:sp>
       <p:sp>
         <p:nvSpPr>
-          <p:cNvPr id="6" name="Rectangle 5"/>
+          <p:cNvPr id="7" name="Rectangle 6"/>
           <p:cNvSpPr/>
           <p:nvPr/>
         </p:nvSpPr>
         <p:spPr>
           <a:xfrm>
-            <a:off x="251999" y="1129284"/>
+            <a:off x="274320" y="1156716"/>
             <a:ext cx="2011680" cy="45720"/>
           </a:xfrm>
           <a:prstGeom prst="rect">
@@ -6193,231 +6327,7 @@
       </p:sp>
       <p:sp>
         <p:nvSpPr>
-          <p:cNvPr id="7" name="TextBox 6"/>
-          <p:cNvSpPr txBox="1"/>
-          <p:nvPr/>
-        </p:nvSpPr>
-        <p:spPr>
-          <a:xfrm>
-            <a:off x="572039" y="1783080"/>
-            <a:ext cx="10881360" cy="3291840"/>
-          </a:xfrm>
-          <a:prstGeom prst="rect">
-            <a:avLst/>
-          </a:prstGeom>
-          <a:noFill/>
-        </p:spPr>
-        <p:txBody>
-          <a:bodyPr wrap="square" lIns="0" tIns="0" rIns="0" bIns="0">
-            <a:spAutoFit/>
-          </a:bodyPr>
-          <a:lstStyle>
-            <a:lvl1pPr marL="342900" indent="-342900">
-              <a:spcBef>
-                <a:spcPts val="1600"/>
-              </a:spcBef>
-              <a:buClr>
-                <a:srgbClr val="0B2B4E"/>
-              </a:buClr>
-              <a:buFont typeface="Calibri"/>
-              <a:buChar char="▪"/>
-              <a:defRPr sz="2400" b="0">
-                <a:solidFill>
-                  <a:srgbClr val="0B2B4E"/>
-                </a:solidFill>
-                <a:latin typeface="Calibri"/>
-              </a:defRPr>
-            </a:lvl1pPr>
-            <a:lvl2pPr marL="685800" indent="-228600">
-              <a:spcBef>
-                <a:spcPts val="300"/>
-              </a:spcBef>
-              <a:buClr>
-                <a:srgbClr val="555B66"/>
-              </a:buClr>
-              <a:buFont typeface="Calibri"/>
-              <a:buChar char="–"/>
-              <a:defRPr sz="2000" b="0">
-                <a:solidFill>
-                  <a:srgbClr val="555B66"/>
-                </a:solidFill>
-                <a:latin typeface="Calibri"/>
-              </a:defRPr>
-            </a:lvl2pPr>
-          </a:lstStyle>
-          <a:p>
-            <a:pPr algn="l"/>
-            <a:r>
-              <a:rPr>
-                <a:latin typeface="Calibri"/>
-              </a:rPr>
-              <a:t>April 2025: Mega Millions raised its ticket price from $2 to $5  (+150%)</a:t>
-            </a:r>
-          </a:p>
-          <a:p>
-            <a:pPr algn="l"/>
-            <a:r>
-              <a:rPr>
-                <a:latin typeface="Calibri"/>
-              </a:rPr>
-              <a:t>In New York, tickets sold per drawing fell from ~1.9 million to ~560,000  (≈ −70%)</a:t>
-            </a:r>
-          </a:p>
-          <a:p>
-            <a:pPr algn="l"/>
-            <a:r>
-              <a:rPr>
-                <a:latin typeface="Calibri"/>
-              </a:rPr>
-              <a:t>We computed  </a:t>
-            </a:r>
-            <a:r>
-              <a:rPr b="1">
-                <a:solidFill>
-                  <a:srgbClr val="0070C0"/>
-                </a:solidFill>
-                <a:latin typeface="Calibri"/>
-              </a:rPr>
-              <a:t>E</a:t>
-            </a:r>
-            <a:r>
-              <a:rPr b="1" baseline="-25000">
-                <a:solidFill>
-                  <a:srgbClr val="0070C0"/>
-                </a:solidFill>
-                <a:latin typeface="Calibri"/>
-              </a:rPr>
-              <a:t>D</a:t>
-            </a:r>
-            <a:r>
-              <a:rPr b="1">
-                <a:solidFill>
-                  <a:srgbClr val="0070C0"/>
-                </a:solidFill>
-                <a:latin typeface="Calibri"/>
-              </a:rPr>
-              <a:t> ≈ −0.47</a:t>
-            </a:r>
-            <a:r>
-              <a:rPr>
-                <a:latin typeface="Calibri"/>
-              </a:rPr>
-              <a:t>  →  inelastic</a:t>
-            </a:r>
-          </a:p>
-          <a:p>
-            <a:pPr algn="l"/>
-            <a:r>
-              <a:rPr b="1">
-                <a:latin typeface="Calibri"/>
-              </a:rPr>
-              <a:t>Inelastic demand suggests revenue should RISE when the price rises. Did it?</a:t>
-            </a:r>
-          </a:p>
-        </p:txBody>
-      </p:sp>
-      <p:sp>
-        <p:nvSpPr>
-          <p:cNvPr id="8" name="Rounded Rectangle 7"/>
-          <p:cNvSpPr/>
-          <p:nvPr/>
-        </p:nvSpPr>
-        <p:spPr>
-          <a:xfrm>
-            <a:off x="1417320" y="5257800"/>
-            <a:ext cx="9326880" cy="777240"/>
-          </a:xfrm>
-          <a:prstGeom prst="roundRect">
-            <a:avLst>
-              <a:gd name="adj" fmla="val 12000"/>
-            </a:avLst>
-          </a:prstGeom>
-          <a:solidFill>
-            <a:srgbClr val="FDF6E6"/>
-          </a:solidFill>
-          <a:ln w="12700">
-            <a:solidFill>
-              <a:srgbClr val="0B2B4E"/>
-            </a:solidFill>
-          </a:ln>
-          <a:effectLst>
-            <a:outerShdw blurRad="50800" dist="38100" dir="2700000" algn="tl" rotWithShape="0">
-              <a:srgbClr val="000000">
-                <a:alpha val="45000"/>
-              </a:srgbClr>
-            </a:outerShdw>
-          </a:effectLst>
-        </p:spPr>
-        <p:style>
-          <a:lnRef idx="1">
-            <a:schemeClr val="accent1"/>
-          </a:lnRef>
-          <a:fillRef idx="3">
-            <a:schemeClr val="accent1"/>
-          </a:fillRef>
-          <a:effectRef idx="2">
-            <a:schemeClr val="accent1"/>
-          </a:effectRef>
-          <a:fontRef idx="minor">
-            <a:schemeClr val="lt1"/>
-          </a:fontRef>
-        </p:style>
-        <p:txBody>
-          <a:bodyPr rtlCol="0" anchor="ctr"/>
-          <a:lstStyle/>
-          <a:p>
-            <a:pPr algn="ctr"/>
-            <a:endParaRPr/>
-          </a:p>
-        </p:txBody>
-      </p:sp>
-      <p:sp>
-        <p:nvSpPr>
-          <p:cNvPr id="9" name="TextBox 8"/>
-          <p:cNvSpPr txBox="1"/>
-          <p:nvPr/>
-        </p:nvSpPr>
-        <p:spPr>
-          <a:xfrm>
-            <a:off x="1600200" y="5367528"/>
-            <a:ext cx="8961120" cy="557784"/>
-          </a:xfrm>
-          <a:prstGeom prst="rect">
-            <a:avLst/>
-          </a:prstGeom>
-          <a:noFill/>
-        </p:spPr>
-        <p:txBody>
-          <a:bodyPr wrap="square" lIns="45720" tIns="0" rIns="45720" bIns="0" anchor="ctr">
-            <a:spAutoFit/>
-          </a:bodyPr>
-          <a:lstStyle/>
-          <a:p>
-            <a:pPr algn="l"/>
-            <a:r>
-              <a:rPr sz="1500" b="1" i="0" u="none">
-                <a:solidFill>
-                  <a:srgbClr val="0B2B4E"/>
-                </a:solidFill>
-                <a:latin typeface="Calibri"/>
-              </a:rPr>
-              <a:t>Caution: </a:t>
-            </a:r>
-            <a:r>
-              <a:rPr sz="1500" b="0" i="0" u="none">
-                <a:solidFill>
-                  <a:srgbClr val="0B2B4E"/>
-                </a:solidFill>
-                <a:latin typeface="Calibri"/>
-              </a:rPr>
-              <a:t>Method 1 approximates % changes – for LARGE changes like this one, the elasticity-revenue rule can mislead</a:t>
-            </a:r>
-          </a:p>
-        </p:txBody>
-      </p:sp>
-      <p:sp>
-        <p:nvSpPr>
-          <p:cNvPr id="10" name="Rectangle 9"/>
+          <p:cNvPr id="8" name="Rectangle 7"/>
           <p:cNvSpPr/>
           <p:nvPr/>
         </p:nvSpPr>
@@ -6462,13 +6372,13 @@
       </p:sp>
       <p:sp>
         <p:nvSpPr>
-          <p:cNvPr id="11" name="Rectangle 10"/>
+          <p:cNvPr id="9" name="Rectangle 8"/>
           <p:cNvSpPr/>
           <p:nvPr/>
         </p:nvSpPr>
         <p:spPr>
           <a:xfrm>
-            <a:off x="251999" y="6524244"/>
+            <a:off x="274320" y="6519672"/>
             <a:ext cx="2011680" cy="45720"/>
           </a:xfrm>
           <a:prstGeom prst="rect">
@@ -6507,14 +6417,14 @@
       </p:sp>
       <p:sp>
         <p:nvSpPr>
-          <p:cNvPr id="12" name="TextBox 11"/>
+          <p:cNvPr id="10" name="TextBox 9"/>
           <p:cNvSpPr txBox="1"/>
           <p:nvPr/>
         </p:nvSpPr>
         <p:spPr>
           <a:xfrm>
-            <a:off x="251999" y="6583680"/>
-            <a:ext cx="10058400" cy="292608"/>
+            <a:off x="274320" y="6565392"/>
+            <a:ext cx="10058400" cy="274320"/>
           </a:xfrm>
           <a:prstGeom prst="rect">
             <a:avLst/>
@@ -6522,34 +6432,41 @@
           <a:noFill/>
         </p:spPr>
         <p:txBody>
-          <a:bodyPr wrap="square" lIns="0" tIns="0" rIns="0" bIns="0">
+          <a:bodyPr wrap="square" lIns="0" tIns="0" rIns="0" bIns="0" anchor="t">
             <a:spAutoFit/>
           </a:bodyPr>
           <a:lstStyle/>
           <a:p>
-            <a:pPr algn="l"/>
-            <a:r>
-              <a:rPr sz="1200" b="0" i="0" u="none">
+            <a:pPr algn="l">
+              <a:spcBef>
+                <a:spcPts val="0"/>
+              </a:spcBef>
+              <a:spcAft>
+                <a:spcPts val="200"/>
+              </a:spcAft>
+            </a:pPr>
+            <a:r>
+              <a:rPr sz="1200" b="0" i="0">
                 <a:solidFill>
                   <a:srgbClr val="555B66"/>
                 </a:solidFill>
                 <a:latin typeface="Calibri"/>
               </a:rPr>
-              <a:t>Management 405  ·  Module 2  ·  Demand Analysis</a:t>
-            </a:r>
-          </a:p>
-        </p:txBody>
-      </p:sp>
-      <p:sp>
-        <p:nvSpPr>
-          <p:cNvPr id="13" name="TextBox 12"/>
+              <a:t>Management 405  ·  Demand Analysis</a:t>
+            </a:r>
+          </a:p>
+        </p:txBody>
+      </p:sp>
+      <p:sp>
+        <p:nvSpPr>
+          <p:cNvPr id="11" name="TextBox 10"/>
           <p:cNvSpPr txBox="1"/>
           <p:nvPr/>
         </p:nvSpPr>
         <p:spPr>
           <a:xfrm>
-            <a:off x="11475720" y="6583680"/>
-            <a:ext cx="502920" cy="292608"/>
+            <a:off x="11338560" y="6565392"/>
+            <a:ext cx="640080" cy="274320"/>
           </a:xfrm>
           <a:prstGeom prst="rect">
             <a:avLst/>
@@ -6557,14 +6474,21 @@
           <a:noFill/>
         </p:spPr>
         <p:txBody>
-          <a:bodyPr wrap="none" lIns="0" tIns="0" rIns="0" bIns="0">
+          <a:bodyPr wrap="square" lIns="0" tIns="0" rIns="0" bIns="0" anchor="t">
             <a:spAutoFit/>
           </a:bodyPr>
           <a:lstStyle/>
           <a:p>
-            <a:pPr algn="r"/>
-            <a:fld id="{2DB18AEB-6F3A-5D2F-99F2-AAFEDB67B91B}" type="slidenum">
-              <a:rPr lang="en-US" sz="1200" dirty="0">
+            <a:pPr algn="r">
+              <a:spcBef>
+                <a:spcPts val="0"/>
+              </a:spcBef>
+              <a:spcAft>
+                <a:spcPts val="200"/>
+              </a:spcAft>
+            </a:pPr>
+            <a:fld id="{47CD56CC-7DF6-479C-85AA-7676A08079F2}" type="slidenum">
+              <a:rPr sz="1200" b="0" i="0" dirty="0">
                 <a:solidFill>
                   <a:srgbClr val="555B66"/>
                 </a:solidFill>
@@ -6572,21 +6496,281 @@
               </a:rPr>
               <a:t>4</a:t>
             </a:fld>
-            <a:endParaRPr lang="en-US" sz="1200" dirty="0">
+          </a:p>
+        </p:txBody>
+      </p:sp>
+      <p:sp>
+        <p:nvSpPr>
+          <p:cNvPr id="12" name="TextBox 11"/>
+          <p:cNvSpPr txBox="1"/>
+          <p:nvPr/>
+        </p:nvSpPr>
+        <p:spPr>
+          <a:xfrm>
+            <a:off x="493776" y="1493671"/>
+            <a:ext cx="10753344" cy="3934667"/>
+          </a:xfrm>
+          <a:prstGeom prst="rect">
+            <a:avLst/>
+          </a:prstGeom>
+          <a:noFill/>
+        </p:spPr>
+        <p:txBody>
+          <a:bodyPr wrap="square" lIns="0" tIns="0" rIns="0" bIns="0" anchor="ctr">
+            <a:spAutoFit/>
+          </a:bodyPr>
+          <a:lstStyle/>
+          <a:p>
+            <a:pPr marL="274320" indent="-237744" algn="l">
+              <a:lnSpc>
+                <a:spcPct val="108000"/>
+              </a:lnSpc>
+              <a:spcBef>
+                <a:spcPts val="0"/>
+              </a:spcBef>
+              <a:spcAft>
+                <a:spcPts val="2000"/>
+              </a:spcAft>
+              <a:buClr>
+                <a:srgbClr val="0B2B4E"/>
+              </a:buClr>
+              <a:buSzPct val="80000"/>
+              <a:buFont typeface="Arial"/>
+              <a:buChar char="▪"/>
+            </a:pPr>
+            <a:r>
+              <a:rPr lang="en-US" sz="2600" b="0" i="0" dirty="0">
+                <a:solidFill>
+                  <a:srgbClr val="0B2B4E"/>
+                </a:solidFill>
+                <a:latin typeface="Calibri"/>
+              </a:rPr>
+              <a:t>April 2025: Mega Millions raises its ticket price from $2 to $5</a:t>
+            </a:r>
+          </a:p>
+          <a:p>
+            <a:pPr marL="274320" indent="-237744" algn="l">
+              <a:lnSpc>
+                <a:spcPct val="108000"/>
+              </a:lnSpc>
+              <a:spcBef>
+                <a:spcPts val="0"/>
+              </a:spcBef>
+              <a:spcAft>
+                <a:spcPts val="2000"/>
+              </a:spcAft>
+              <a:buClr>
+                <a:srgbClr val="0B2B4E"/>
+              </a:buClr>
+              <a:buSzPct val="80000"/>
+              <a:buFont typeface="Arial"/>
+              <a:buChar char="▪"/>
+            </a:pPr>
+            <a:r>
+              <a:rPr lang="en-US" sz="2600" b="0" i="0" dirty="0">
+                <a:solidFill>
+                  <a:srgbClr val="0B2B4E"/>
+                </a:solidFill>
+                <a:latin typeface="Calibri"/>
+              </a:rPr>
+              <a:t>As a result, in Massachusetts, weekly ticket sales fell from about 142,000 to about 100,000</a:t>
+            </a:r>
+          </a:p>
+          <a:p>
+            <a:pPr marL="274320" indent="-237744" algn="l">
+              <a:lnSpc>
+                <a:spcPct val="108000"/>
+              </a:lnSpc>
+              <a:spcBef>
+                <a:spcPts val="0"/>
+              </a:spcBef>
+              <a:spcAft>
+                <a:spcPts val="2000"/>
+              </a:spcAft>
+              <a:buClr>
+                <a:srgbClr val="0B2B4E"/>
+              </a:buClr>
+              <a:buSzPct val="80000"/>
+              <a:buFont typeface="Arial"/>
+              <a:buChar char="▪"/>
+            </a:pPr>
+            <a:r>
+              <a:rPr sz="2600" b="0" i="0" dirty="0">
+                <a:solidFill>
+                  <a:srgbClr val="0B2B4E"/>
+                </a:solidFill>
+                <a:latin typeface="Calibri"/>
+              </a:rPr>
+              <a:t>We computed E</a:t>
+            </a:r>
+            <a:r>
+              <a:rPr sz="2600" b="0" i="0" baseline="-25000" dirty="0">
+                <a:solidFill>
+                  <a:srgbClr val="0B2B4E"/>
+                </a:solidFill>
+                <a:latin typeface="Calibri"/>
+              </a:rPr>
+              <a:t>D</a:t>
+            </a:r>
+            <a:r>
+              <a:rPr sz="2600" b="0" i="0" dirty="0">
+                <a:solidFill>
+                  <a:srgbClr val="0B2B4E"/>
+                </a:solidFill>
+                <a:latin typeface="Calibri"/>
+              </a:rPr>
+              <a:t> = </a:t>
+            </a:r>
+            <a:r>
+              <a:rPr sz="2600" b="1" i="0" dirty="0">
+                <a:solidFill>
+                  <a:srgbClr val="0070C0"/>
+                </a:solidFill>
+                <a:latin typeface="Calibri"/>
+              </a:rPr>
+              <a:t>−0.2</a:t>
+            </a:r>
+            <a:endParaRPr lang="fr-FR" sz="2600" b="1" i="0" dirty="0">
               <a:solidFill>
-                <a:srgbClr val="555B66"/>
+                <a:srgbClr val="0070C0"/>
               </a:solidFill>
               <a:latin typeface="Calibri"/>
             </a:endParaRPr>
           </a:p>
+          <a:p>
+            <a:pPr marL="274320" indent="-237744" algn="l">
+              <a:lnSpc>
+                <a:spcPct val="100000"/>
+              </a:lnSpc>
+              <a:spcBef>
+                <a:spcPts val="0"/>
+              </a:spcBef>
+              <a:spcAft>
+                <a:spcPts val="2000"/>
+              </a:spcAft>
+              <a:buClr>
+                <a:srgbClr val="0B2B4E"/>
+              </a:buClr>
+              <a:buSzPct val="80000"/>
+              <a:buFont typeface="Arial"/>
+              <a:buChar char="▪"/>
+            </a:pPr>
+            <a:r>
+              <a:rPr lang="en-US" sz="2600" dirty="0">
+                <a:solidFill>
+                  <a:srgbClr val="002060"/>
+                </a:solidFill>
+                <a:latin typeface="Calibri"/>
+              </a:rPr>
+              <a:t>“When ticket prices went up from $2 to $5 last April, Massachusetts State Lottery saw fewer people buying tickets but much higher profits. Sales dropped by 30% while revenue climbed…” (</a:t>
+            </a:r>
+            <a:r>
+              <a:rPr lang="en-US" sz="2600" dirty="0">
+                <a:solidFill>
+                  <a:srgbClr val="002060"/>
+                </a:solidFill>
+                <a:latin typeface="Calibri"/>
+                <a:hlinkClick r:id="rId4"/>
+              </a:rPr>
+              <a:t>Source</a:t>
+            </a:r>
+            <a:r>
+              <a:rPr lang="en-US" sz="2600" dirty="0">
+                <a:solidFill>
+                  <a:srgbClr val="002060"/>
+                </a:solidFill>
+                <a:latin typeface="Calibri"/>
+              </a:rPr>
+              <a:t>)</a:t>
+            </a:r>
+            <a:endParaRPr sz="2600" i="0" dirty="0">
+              <a:solidFill>
+                <a:srgbClr val="002060"/>
+              </a:solidFill>
+              <a:latin typeface="Calibri"/>
+            </a:endParaRPr>
+          </a:p>
+          <a:p>
+            <a:pPr marL="274320" indent="-237744" algn="l">
+              <a:lnSpc>
+                <a:spcPct val="108000"/>
+              </a:lnSpc>
+              <a:spcBef>
+                <a:spcPts val="0"/>
+              </a:spcBef>
+              <a:spcAft>
+                <a:spcPts val="600"/>
+              </a:spcAft>
+              <a:buClr>
+                <a:srgbClr val="0B2B4E"/>
+              </a:buClr>
+              <a:buSzPct val="80000"/>
+              <a:buFont typeface="Arial"/>
+              <a:buChar char="▪"/>
+            </a:pPr>
+            <a:r>
+              <a:rPr sz="2600" b="1" i="0" dirty="0">
+                <a:solidFill>
+                  <a:srgbClr val="0B2B4E"/>
+                </a:solidFill>
+                <a:latin typeface="Calibri"/>
+              </a:rPr>
+              <a:t>Is the </a:t>
+            </a:r>
+            <a:r>
+              <a:rPr lang="fr-FR" sz="2600" b="1" i="0" dirty="0">
+                <a:solidFill>
+                  <a:srgbClr val="0B2B4E"/>
+                </a:solidFill>
+                <a:latin typeface="Calibri"/>
+              </a:rPr>
+              <a:t>article</a:t>
+            </a:r>
+            <a:r>
+              <a:rPr sz="2600" b="1" i="0" dirty="0">
+                <a:solidFill>
+                  <a:srgbClr val="0B2B4E"/>
+                </a:solidFill>
+                <a:latin typeface="Calibri"/>
+              </a:rPr>
+              <a:t> right that revenue r</a:t>
+            </a:r>
+            <a:r>
+              <a:rPr lang="fr-FR" sz="2600" b="1" i="0">
+                <a:solidFill>
+                  <a:srgbClr val="0B2B4E"/>
+                </a:solidFill>
+                <a:latin typeface="Calibri"/>
+              </a:rPr>
+              <a:t>ose</a:t>
+            </a:r>
+            <a:r>
+              <a:rPr sz="2600" b="1" i="0">
+                <a:solidFill>
+                  <a:srgbClr val="0B2B4E"/>
+                </a:solidFill>
+                <a:latin typeface="Calibri"/>
+              </a:rPr>
+              <a:t> </a:t>
+            </a:r>
+            <a:r>
+              <a:rPr sz="2600" b="1" i="0" dirty="0">
+                <a:solidFill>
+                  <a:srgbClr val="0B2B4E"/>
+                </a:solidFill>
+                <a:latin typeface="Calibri"/>
+              </a:rPr>
+              <a:t>when the price went from $2 to $5?</a:t>
+            </a:r>
+          </a:p>
         </p:txBody>
       </p:sp>
       <p:grpSp>
         <p:nvGrpSpPr>
-          <p:cNvPr id="9700" name="Group 14">
+          <p:cNvPr id="13" name="Group 14">
             <a:extLst>
               <a:ext uri="{FF2B5EF4-FFF2-40B4-BE49-F238E27FC236}">
-                <a16:creationId xmlns:a16="http://schemas.microsoft.com/office/drawing/2014/main" id="{C7881A0F-62FF-0536-16AD-55B1DC27DD3D}"/>
+                <a16:creationId xmlns:a16="http://schemas.microsoft.com/office/drawing/2014/main" id="{5624855F-1002-EDBD-33EC-FE2932990C2B}"/>
               </a:ext>
             </a:extLst>
           </p:cNvPr>
@@ -6603,7 +6787,13 @@
         </p:grpSpPr>
         <p:sp>
           <p:nvSpPr>
-            <p:cNvPr id="9701" name="Rectangle 8"/>
+            <p:cNvPr id="14" name="Rectangle 8">
+              <a:extLst>
+                <a:ext uri="{FF2B5EF4-FFF2-40B4-BE49-F238E27FC236}">
+                  <a16:creationId xmlns:a16="http://schemas.microsoft.com/office/drawing/2014/main" id="{30D584E5-ECDB-530C-2D32-26B664624E4E}"/>
+                </a:ext>
+              </a:extLst>
+            </p:cNvPr>
             <p:cNvSpPr/>
             <p:nvPr/>
           </p:nvSpPr>
@@ -6698,7 +6888,13 @@
         </p:sp>
         <p:sp>
           <p:nvSpPr>
-            <p:cNvPr id="9702" name="TextBox 9"/>
+            <p:cNvPr id="15" name="TextBox 9">
+              <a:extLst>
+                <a:ext uri="{FF2B5EF4-FFF2-40B4-BE49-F238E27FC236}">
+                  <a16:creationId xmlns:a16="http://schemas.microsoft.com/office/drawing/2014/main" id="{2E2B3134-1BF6-4BD1-8217-AE3290A16E66}"/>
+                </a:ext>
+              </a:extLst>
+            </p:cNvPr>
             <p:cNvSpPr txBox="1"/>
             <p:nvPr/>
           </p:nvSpPr>
@@ -6758,7 +6954,7 @@
                             </p:stCondLst>
                             <p:childTnLst>
                               <p:par>
-                                <p:cTn id="5" presetID="10" presetClass="entr" presetSubtype="0" fill="hold" grpId="0" nodeType="clickEffect">
+                                <p:cTn id="5" presetID="10" presetClass="entr" presetSubtype="0" fill="hold" nodeType="clickEffect">
                                   <p:stCondLst>
                                     <p:cond delay="0"/>
                                   </p:stCondLst>
@@ -6771,11 +6967,7 @@
                                           </p:stCondLst>
                                         </p:cTn>
                                         <p:tgtEl>
-                                          <p:spTgt spid="7">
-                                            <p:txEl>
-                                              <p:pRg st="1" end="1"/>
-                                            </p:txEl>
-                                          </p:spTgt>
+                                          <p:spTgt spid="13"/>
                                         </p:tgtEl>
                                         <p:attrNameLst>
                                           <p:attrName>style.visibility</p:attrName>
@@ -6789,186 +6981,7 @@
                                       <p:cBhvr>
                                         <p:cTn id="7" dur="500"/>
                                         <p:tgtEl>
-                                          <p:spTgt spid="7">
-                                            <p:txEl>
-                                              <p:pRg st="1" end="1"/>
-                                            </p:txEl>
-                                          </p:spTgt>
-                                        </p:tgtEl>
-                                      </p:cBhvr>
-                                    </p:animEffect>
-                                  </p:childTnLst>
-                                </p:cTn>
-                              </p:par>
-                            </p:childTnLst>
-                          </p:cTn>
-                        </p:par>
-                      </p:childTnLst>
-                    </p:cTn>
-                  </p:par>
-                  <p:par>
-                    <p:cTn id="8" fill="hold">
-                      <p:stCondLst>
-                        <p:cond delay="indefinite"/>
-                      </p:stCondLst>
-                      <p:childTnLst>
-                        <p:par>
-                          <p:cTn id="9" fill="hold">
-                            <p:stCondLst>
-                              <p:cond delay="0"/>
-                            </p:stCondLst>
-                            <p:childTnLst>
-                              <p:par>
-                                <p:cTn id="10" presetID="10" presetClass="entr" presetSubtype="0" fill="hold" grpId="0" nodeType="clickEffect">
-                                  <p:stCondLst>
-                                    <p:cond delay="0"/>
-                                  </p:stCondLst>
-                                  <p:childTnLst>
-                                    <p:set>
-                                      <p:cBhvr>
-                                        <p:cTn id="11" dur="1" fill="hold">
-                                          <p:stCondLst>
-                                            <p:cond delay="0"/>
-                                          </p:stCondLst>
-                                        </p:cTn>
-                                        <p:tgtEl>
-                                          <p:spTgt spid="7">
-                                            <p:txEl>
-                                              <p:pRg st="2" end="2"/>
-                                            </p:txEl>
-                                          </p:spTgt>
-                                        </p:tgtEl>
-                                        <p:attrNameLst>
-                                          <p:attrName>style.visibility</p:attrName>
-                                        </p:attrNameLst>
-                                      </p:cBhvr>
-                                      <p:to>
-                                        <p:strVal val="visible"/>
-                                      </p:to>
-                                    </p:set>
-                                    <p:animEffect transition="in" filter="fade">
-                                      <p:cBhvr>
-                                        <p:cTn id="12" dur="500"/>
-                                        <p:tgtEl>
-                                          <p:spTgt spid="7">
-                                            <p:txEl>
-                                              <p:pRg st="2" end="2"/>
-                                            </p:txEl>
-                                          </p:spTgt>
-                                        </p:tgtEl>
-                                      </p:cBhvr>
-                                    </p:animEffect>
-                                  </p:childTnLst>
-                                </p:cTn>
-                              </p:par>
-                            </p:childTnLst>
-                          </p:cTn>
-                        </p:par>
-                      </p:childTnLst>
-                    </p:cTn>
-                  </p:par>
-                  <p:par>
-                    <p:cTn id="13" fill="hold">
-                      <p:stCondLst>
-                        <p:cond delay="indefinite"/>
-                      </p:stCondLst>
-                      <p:childTnLst>
-                        <p:par>
-                          <p:cTn id="14" fill="hold">
-                            <p:stCondLst>
-                              <p:cond delay="0"/>
-                            </p:stCondLst>
-                            <p:childTnLst>
-                              <p:par>
-                                <p:cTn id="15" presetID="10" presetClass="entr" presetSubtype="0" fill="hold" grpId="0" nodeType="clickEffect">
-                                  <p:stCondLst>
-                                    <p:cond delay="0"/>
-                                  </p:stCondLst>
-                                  <p:childTnLst>
-                                    <p:set>
-                                      <p:cBhvr>
-                                        <p:cTn id="16" dur="1" fill="hold">
-                                          <p:stCondLst>
-                                            <p:cond delay="0"/>
-                                          </p:stCondLst>
-                                        </p:cTn>
-                                        <p:tgtEl>
-                                          <p:spTgt spid="7">
-                                            <p:txEl>
-                                              <p:pRg st="3" end="3"/>
-                                            </p:txEl>
-                                          </p:spTgt>
-                                        </p:tgtEl>
-                                        <p:attrNameLst>
-                                          <p:attrName>style.visibility</p:attrName>
-                                        </p:attrNameLst>
-                                      </p:cBhvr>
-                                      <p:to>
-                                        <p:strVal val="visible"/>
-                                      </p:to>
-                                    </p:set>
-                                    <p:animEffect transition="in" filter="fade">
-                                      <p:cBhvr>
-                                        <p:cTn id="17" dur="500"/>
-                                        <p:tgtEl>
-                                          <p:spTgt spid="7">
-                                            <p:txEl>
-                                              <p:pRg st="3" end="3"/>
-                                            </p:txEl>
-                                          </p:spTgt>
-                                        </p:tgtEl>
-                                      </p:cBhvr>
-                                    </p:animEffect>
-                                  </p:childTnLst>
-                                </p:cTn>
-                              </p:par>
-                            </p:childTnLst>
-                          </p:cTn>
-                        </p:par>
-                      </p:childTnLst>
-                    </p:cTn>
-                  </p:par>
-                  <p:par>
-                    <p:cTn id="18" fill="hold">
-                      <p:stCondLst>
-                        <p:cond delay="indefinite"/>
-                      </p:stCondLst>
-                      <p:childTnLst>
-                        <p:par>
-                          <p:cTn id="19" fill="hold">
-                            <p:stCondLst>
-                              <p:cond delay="0"/>
-                            </p:stCondLst>
-                            <p:childTnLst>
-                              <p:par>
-                                <p:cTn id="20" presetID="10" presetClass="entr" presetSubtype="0" fill="hold" nodeType="clickEffect">
-                                  <p:stCondLst>
-                                    <p:cond delay="0"/>
-                                  </p:stCondLst>
-                                  <p:childTnLst>
-                                    <p:set>
-                                      <p:cBhvr>
-                                        <p:cTn id="21" dur="1" fill="hold">
-                                          <p:stCondLst>
-                                            <p:cond delay="0"/>
-                                          </p:stCondLst>
-                                        </p:cTn>
-                                        <p:tgtEl>
-                                          <p:spTgt spid="9700"/>
-                                        </p:tgtEl>
-                                        <p:attrNameLst>
-                                          <p:attrName>style.visibility</p:attrName>
-                                        </p:attrNameLst>
-                                      </p:cBhvr>
-                                      <p:to>
-                                        <p:strVal val="visible"/>
-                                      </p:to>
-                                    </p:set>
-                                    <p:animEffect transition="in" filter="fade">
-                                      <p:cBhvr>
-                                        <p:cTn id="22" dur="500"/>
-                                        <p:tgtEl>
-                                          <p:spTgt spid="9700"/>
+                                          <p:spTgt spid="13"/>
                                         </p:tgtEl>
                                       </p:cBhvr>
                                     </p:animEffect>
@@ -7002,9 +7015,6 @@
         </p:cTn>
       </p:par>
     </p:tnLst>
-    <p:bldLst>
-      <p:bldP spid="7" grpId="0" build="p"/>
-    </p:bldLst>
   </p:timing>
 </p:sld>
 </file>
@@ -9226,6 +9236,970 @@
       <p:bldP spid="10" grpId="0" build="p"/>
     </p:bldLst>
   </p:timing>
+</p:sld>
+</file>
+
+<file path=ppt/slides/slide7.xml><?xml version="1.0" encoding="utf-8"?>
+<p:sld xmlns:a="http://schemas.openxmlformats.org/drawingml/2006/main" xmlns:p="http://schemas.openxmlformats.org/presentationml/2006/main" xmlns:r="http://schemas.openxmlformats.org/officeDocument/2006/relationships">
+  <p:cSld>
+    <p:spTree>
+      <p:nvGrpSpPr>
+        <p:cNvPr id="1" name=""/>
+        <p:cNvGrpSpPr/>
+        <p:nvPr/>
+      </p:nvGrpSpPr>
+      <p:grpSpPr/>
+      <p:sp>
+        <p:nvSpPr>
+          <p:cNvPr id="2" name="Rectangle 1"/>
+          <p:cNvSpPr/>
+          <p:nvPr/>
+        </p:nvSpPr>
+        <p:spPr>
+          <a:xfrm>
+            <a:off x="0" y="0"/>
+            <a:ext cx="12191695" cy="384048"/>
+          </a:xfrm>
+          <a:prstGeom prst="rect">
+            <a:avLst/>
+          </a:prstGeom>
+          <a:solidFill>
+            <a:srgbClr val="0B2B4E"/>
+          </a:solidFill>
+          <a:ln>
+            <a:noFill/>
+          </a:ln>
+          <a:effectLst/>
+        </p:spPr>
+        <p:style>
+          <a:lnRef idx="1">
+            <a:schemeClr val="accent1"/>
+          </a:lnRef>
+          <a:fillRef idx="3">
+            <a:schemeClr val="accent1"/>
+          </a:fillRef>
+          <a:effectRef idx="2">
+            <a:schemeClr val="accent1"/>
+          </a:effectRef>
+          <a:fontRef idx="minor">
+            <a:schemeClr val="lt1"/>
+          </a:fontRef>
+        </p:style>
+        <p:txBody>
+          <a:bodyPr rtlCol="0" anchor="ctr"/>
+          <a:lstStyle/>
+          <a:p>
+            <a:pPr algn="ctr"/>
+          </a:p>
+        </p:txBody>
+      </p:sp>
+      <p:sp>
+        <p:nvSpPr>
+          <p:cNvPr id="3" name="TextBox 2"/>
+          <p:cNvSpPr txBox="1"/>
+          <p:nvPr/>
+        </p:nvSpPr>
+        <p:spPr>
+          <a:xfrm>
+            <a:off x="251999" y="0"/>
+            <a:ext cx="10972800" cy="384048"/>
+          </a:xfrm>
+          <a:prstGeom prst="rect">
+            <a:avLst/>
+          </a:prstGeom>
+          <a:noFill/>
+        </p:spPr>
+        <p:txBody>
+          <a:bodyPr wrap="square" lIns="0" rIns="0" tIns="0" bIns="0" anchor="ctr">
+            <a:spAutoFit/>
+          </a:bodyPr>
+          <a:lstStyle/>
+          <a:p>
+            <a:pPr algn="l"/>
+            <a:r>
+              <a:rPr sz="1600" b="1" i="0" u="none">
+                <a:solidFill>
+                  <a:srgbClr val="FFFFFF"/>
+                </a:solidFill>
+                <a:latin typeface="Calibri"/>
+              </a:rPr>
+              <a:t>Demand Analysis · Elasticity and Revenue</a:t>
+            </a:r>
+          </a:p>
+        </p:txBody>
+      </p:sp>
+      <p:sp>
+        <p:nvSpPr>
+          <p:cNvPr id="4" name="TextBox 3"/>
+          <p:cNvSpPr txBox="1"/>
+          <p:nvPr/>
+        </p:nvSpPr>
+        <p:spPr>
+          <a:xfrm>
+            <a:off x="251999" y="502920"/>
+            <a:ext cx="11687697" cy="640080"/>
+          </a:xfrm>
+          <a:prstGeom prst="rect">
+            <a:avLst/>
+          </a:prstGeom>
+          <a:noFill/>
+        </p:spPr>
+        <p:txBody>
+          <a:bodyPr wrap="square" lIns="0" rIns="0" tIns="0" bIns="0">
+            <a:spAutoFit/>
+          </a:bodyPr>
+          <a:lstStyle/>
+          <a:p>
+            <a:pPr algn="l"/>
+            <a:r>
+              <a:rPr sz="3200" b="1" i="0" u="none">
+                <a:solidFill>
+                  <a:srgbClr val="0B2B4E"/>
+                </a:solidFill>
+                <a:latin typeface="Calibri"/>
+              </a:rPr>
+              <a:t>Poll: Lottery Revenue</a:t>
+            </a:r>
+          </a:p>
+        </p:txBody>
+      </p:sp>
+      <p:sp>
+        <p:nvSpPr>
+          <p:cNvPr id="5" name="Rectangle 4"/>
+          <p:cNvSpPr/>
+          <p:nvPr/>
+        </p:nvSpPr>
+        <p:spPr>
+          <a:xfrm>
+            <a:off x="251999" y="1143000"/>
+            <a:ext cx="11687697" cy="18288"/>
+          </a:xfrm>
+          <a:prstGeom prst="rect">
+            <a:avLst/>
+          </a:prstGeom>
+          <a:solidFill>
+            <a:srgbClr val="C8CDD3"/>
+          </a:solidFill>
+          <a:ln>
+            <a:noFill/>
+          </a:ln>
+          <a:effectLst/>
+        </p:spPr>
+        <p:style>
+          <a:lnRef idx="1">
+            <a:schemeClr val="accent1"/>
+          </a:lnRef>
+          <a:fillRef idx="3">
+            <a:schemeClr val="accent1"/>
+          </a:fillRef>
+          <a:effectRef idx="2">
+            <a:schemeClr val="accent1"/>
+          </a:effectRef>
+          <a:fontRef idx="minor">
+            <a:schemeClr val="lt1"/>
+          </a:fontRef>
+        </p:style>
+        <p:txBody>
+          <a:bodyPr rtlCol="0" anchor="ctr"/>
+          <a:lstStyle/>
+          <a:p>
+            <a:pPr algn="ctr"/>
+          </a:p>
+        </p:txBody>
+      </p:sp>
+      <p:sp>
+        <p:nvSpPr>
+          <p:cNvPr id="6" name="Rectangle 5"/>
+          <p:cNvSpPr/>
+          <p:nvPr/>
+        </p:nvSpPr>
+        <p:spPr>
+          <a:xfrm>
+            <a:off x="251999" y="1129284"/>
+            <a:ext cx="2011680" cy="45720"/>
+          </a:xfrm>
+          <a:prstGeom prst="rect">
+            <a:avLst/>
+          </a:prstGeom>
+          <a:solidFill>
+            <a:srgbClr val="E09F3E"/>
+          </a:solidFill>
+          <a:ln>
+            <a:noFill/>
+          </a:ln>
+          <a:effectLst/>
+        </p:spPr>
+        <p:style>
+          <a:lnRef idx="1">
+            <a:schemeClr val="accent1"/>
+          </a:lnRef>
+          <a:fillRef idx="3">
+            <a:schemeClr val="accent1"/>
+          </a:fillRef>
+          <a:effectRef idx="2">
+            <a:schemeClr val="accent1"/>
+          </a:effectRef>
+          <a:fontRef idx="minor">
+            <a:schemeClr val="lt1"/>
+          </a:fontRef>
+        </p:style>
+        <p:txBody>
+          <a:bodyPr rtlCol="0" anchor="ctr"/>
+          <a:lstStyle/>
+          <a:p>
+            <a:pPr algn="ctr"/>
+          </a:p>
+        </p:txBody>
+      </p:sp>
+      <p:sp>
+        <p:nvSpPr>
+          <p:cNvPr id="7" name="TextBox 6"/>
+          <p:cNvSpPr txBox="1"/>
+          <p:nvPr/>
+        </p:nvSpPr>
+        <p:spPr>
+          <a:xfrm>
+            <a:off x="251999" y="3108960"/>
+            <a:ext cx="11687697" cy="731520"/>
+          </a:xfrm>
+          <a:prstGeom prst="rect">
+            <a:avLst/>
+          </a:prstGeom>
+          <a:noFill/>
+        </p:spPr>
+        <p:txBody>
+          <a:bodyPr wrap="square" lIns="0" rIns="0" tIns="0" bIns="0">
+            <a:spAutoFit/>
+          </a:bodyPr>
+          <a:lstStyle/>
+          <a:p>
+            <a:pPr algn="ctr"/>
+            <a:r>
+              <a:rPr sz="2000" b="0" i="1" u="none">
+                <a:solidFill>
+                  <a:srgbClr val="555B66"/>
+                </a:solidFill>
+                <a:latin typeface="Calibri"/>
+              </a:rPr>
+              <a:t>[ PollEverywhere slide – insert your poll here ]</a:t>
+            </a:r>
+          </a:p>
+        </p:txBody>
+      </p:sp>
+      <p:sp>
+        <p:nvSpPr>
+          <p:cNvPr id="8" name="Rectangle 7"/>
+          <p:cNvSpPr/>
+          <p:nvPr/>
+        </p:nvSpPr>
+        <p:spPr>
+          <a:xfrm>
+            <a:off x="0" y="6537960"/>
+            <a:ext cx="12191695" cy="18288"/>
+          </a:xfrm>
+          <a:prstGeom prst="rect">
+            <a:avLst/>
+          </a:prstGeom>
+          <a:solidFill>
+            <a:srgbClr val="C8CDD3"/>
+          </a:solidFill>
+          <a:ln>
+            <a:noFill/>
+          </a:ln>
+          <a:effectLst/>
+        </p:spPr>
+        <p:style>
+          <a:lnRef idx="1">
+            <a:schemeClr val="accent1"/>
+          </a:lnRef>
+          <a:fillRef idx="3">
+            <a:schemeClr val="accent1"/>
+          </a:fillRef>
+          <a:effectRef idx="2">
+            <a:schemeClr val="accent1"/>
+          </a:effectRef>
+          <a:fontRef idx="minor">
+            <a:schemeClr val="lt1"/>
+          </a:fontRef>
+        </p:style>
+        <p:txBody>
+          <a:bodyPr rtlCol="0" anchor="ctr"/>
+          <a:lstStyle/>
+          <a:p>
+            <a:pPr algn="ctr"/>
+          </a:p>
+        </p:txBody>
+      </p:sp>
+      <p:sp>
+        <p:nvSpPr>
+          <p:cNvPr id="9" name="Rectangle 8"/>
+          <p:cNvSpPr/>
+          <p:nvPr/>
+        </p:nvSpPr>
+        <p:spPr>
+          <a:xfrm>
+            <a:off x="251999" y="6524244"/>
+            <a:ext cx="2011680" cy="45720"/>
+          </a:xfrm>
+          <a:prstGeom prst="rect">
+            <a:avLst/>
+          </a:prstGeom>
+          <a:solidFill>
+            <a:srgbClr val="E09F3E"/>
+          </a:solidFill>
+          <a:ln>
+            <a:noFill/>
+          </a:ln>
+          <a:effectLst/>
+        </p:spPr>
+        <p:style>
+          <a:lnRef idx="1">
+            <a:schemeClr val="accent1"/>
+          </a:lnRef>
+          <a:fillRef idx="3">
+            <a:schemeClr val="accent1"/>
+          </a:fillRef>
+          <a:effectRef idx="2">
+            <a:schemeClr val="accent1"/>
+          </a:effectRef>
+          <a:fontRef idx="minor">
+            <a:schemeClr val="lt1"/>
+          </a:fontRef>
+        </p:style>
+        <p:txBody>
+          <a:bodyPr rtlCol="0" anchor="ctr"/>
+          <a:lstStyle/>
+          <a:p>
+            <a:pPr algn="ctr"/>
+          </a:p>
+        </p:txBody>
+      </p:sp>
+      <p:sp>
+        <p:nvSpPr>
+          <p:cNvPr id="10" name="TextBox 9"/>
+          <p:cNvSpPr txBox="1"/>
+          <p:nvPr/>
+        </p:nvSpPr>
+        <p:spPr>
+          <a:xfrm>
+            <a:off x="251999" y="6583680"/>
+            <a:ext cx="10058400" cy="292608"/>
+          </a:xfrm>
+          <a:prstGeom prst="rect">
+            <a:avLst/>
+          </a:prstGeom>
+          <a:noFill/>
+        </p:spPr>
+        <p:txBody>
+          <a:bodyPr wrap="square" lIns="0" rIns="0" tIns="0" bIns="0">
+            <a:spAutoFit/>
+          </a:bodyPr>
+          <a:lstStyle/>
+          <a:p>
+            <a:pPr algn="l"/>
+            <a:r>
+              <a:rPr sz="1200" b="0" i="0" u="none">
+                <a:solidFill>
+                  <a:srgbClr val="555B66"/>
+                </a:solidFill>
+                <a:latin typeface="Calibri"/>
+              </a:rPr>
+              <a:t>Management 405  ·  Demand Analysis</a:t>
+            </a:r>
+          </a:p>
+        </p:txBody>
+      </p:sp>
+      <p:sp>
+        <p:nvSpPr>
+          <p:cNvPr id="11" name="TextBox 10"/>
+          <p:cNvSpPr txBox="1"/>
+          <p:nvPr/>
+        </p:nvSpPr>
+        <p:spPr>
+          <a:xfrm>
+            <a:off x="11475720" y="6583680"/>
+            <a:ext cx="502920" cy="292608"/>
+          </a:xfrm>
+          <a:prstGeom prst="rect">
+            <a:avLst/>
+          </a:prstGeom>
+          <a:noFill/>
+        </p:spPr>
+        <p:txBody>
+          <a:bodyPr wrap="none" lIns="0" rIns="0" tIns="0" bIns="0">
+            <a:spAutoFit/>
+          </a:bodyPr>
+          <a:lstStyle/>
+          <a:p>
+            <a:pPr algn="r"/>
+            <a:fld id="{DD0FF23F-2665-581F-B7D1-2CC5B078E18B}" type="slidenum">
+              <a:rPr lang="en-US" sz="1200" dirty="0">
+                <a:solidFill>
+                  <a:srgbClr val="555B66"/>
+                </a:solidFill>
+                <a:latin typeface="Calibri"/>
+              </a:rPr>
+              <a:t>5</a:t>
+            </a:fld>
+          </a:p>
+        </p:txBody>
+      </p:sp>
+    </p:spTree>
+  </p:cSld>
+  <p:clrMapOvr>
+    <a:masterClrMapping/>
+  </p:clrMapOvr>
+</p:sld>
+</file>
+
+<file path=ppt/slides/slide8.xml><?xml version="1.0" encoding="utf-8"?>
+<p:sld xmlns:a="http://schemas.openxmlformats.org/drawingml/2006/main" xmlns:p="http://schemas.openxmlformats.org/presentationml/2006/main" xmlns:r="http://schemas.openxmlformats.org/officeDocument/2006/relationships">
+  <p:cSld>
+    <p:spTree>
+      <p:nvGrpSpPr>
+        <p:cNvPr id="1" name=""/>
+        <p:cNvGrpSpPr/>
+        <p:nvPr/>
+      </p:nvGrpSpPr>
+      <p:grpSpPr/>
+      <p:sp>
+        <p:nvSpPr>
+          <p:cNvPr id="2" name="Rectangle 1"/>
+          <p:cNvSpPr/>
+          <p:nvPr/>
+        </p:nvSpPr>
+        <p:spPr>
+          <a:xfrm>
+            <a:off x="0" y="0"/>
+            <a:ext cx="12191695" cy="384048"/>
+          </a:xfrm>
+          <a:prstGeom prst="rect">
+            <a:avLst/>
+          </a:prstGeom>
+          <a:solidFill>
+            <a:srgbClr val="0B2B4E"/>
+          </a:solidFill>
+          <a:ln>
+            <a:noFill/>
+          </a:ln>
+          <a:effectLst/>
+        </p:spPr>
+        <p:style>
+          <a:lnRef idx="1">
+            <a:schemeClr val="accent1"/>
+          </a:lnRef>
+          <a:fillRef idx="3">
+            <a:schemeClr val="accent1"/>
+          </a:fillRef>
+          <a:effectRef idx="2">
+            <a:schemeClr val="accent1"/>
+          </a:effectRef>
+          <a:fontRef idx="minor">
+            <a:schemeClr val="lt1"/>
+          </a:fontRef>
+        </p:style>
+        <p:txBody>
+          <a:bodyPr rtlCol="0" anchor="ctr"/>
+          <a:lstStyle/>
+          <a:p>
+            <a:pPr algn="ctr"/>
+          </a:p>
+        </p:txBody>
+      </p:sp>
+      <p:sp>
+        <p:nvSpPr>
+          <p:cNvPr id="3" name="TextBox 2"/>
+          <p:cNvSpPr txBox="1"/>
+          <p:nvPr/>
+        </p:nvSpPr>
+        <p:spPr>
+          <a:xfrm>
+            <a:off x="251999" y="0"/>
+            <a:ext cx="10972800" cy="384048"/>
+          </a:xfrm>
+          <a:prstGeom prst="rect">
+            <a:avLst/>
+          </a:prstGeom>
+          <a:noFill/>
+        </p:spPr>
+        <p:txBody>
+          <a:bodyPr wrap="square" lIns="0" rIns="0" tIns="0" bIns="0" anchor="ctr">
+            <a:spAutoFit/>
+          </a:bodyPr>
+          <a:lstStyle/>
+          <a:p>
+            <a:pPr algn="l"/>
+            <a:r>
+              <a:rPr sz="1600" b="1" i="0" u="none">
+                <a:solidFill>
+                  <a:srgbClr val="FFFFFF"/>
+                </a:solidFill>
+                <a:latin typeface="Calibri"/>
+              </a:rPr>
+              <a:t>Demand Analysis · Elasticity and Revenue</a:t>
+            </a:r>
+          </a:p>
+        </p:txBody>
+      </p:sp>
+      <p:sp>
+        <p:nvSpPr>
+          <p:cNvPr id="4" name="TextBox 3"/>
+          <p:cNvSpPr txBox="1"/>
+          <p:nvPr/>
+        </p:nvSpPr>
+        <p:spPr>
+          <a:xfrm>
+            <a:off x="251999" y="502920"/>
+            <a:ext cx="11687697" cy="640080"/>
+          </a:xfrm>
+          <a:prstGeom prst="rect">
+            <a:avLst/>
+          </a:prstGeom>
+          <a:noFill/>
+        </p:spPr>
+        <p:txBody>
+          <a:bodyPr wrap="square" lIns="0" rIns="0" tIns="0" bIns="0">
+            <a:spAutoFit/>
+          </a:bodyPr>
+          <a:lstStyle/>
+          <a:p>
+            <a:pPr algn="l"/>
+            <a:r>
+              <a:rPr sz="3200" b="1" i="0" u="none">
+                <a:solidFill>
+                  <a:srgbClr val="0B2B4E"/>
+                </a:solidFill>
+                <a:latin typeface="Calibri"/>
+              </a:rPr>
+              <a:t>Solution: Lottery Revenue</a:t>
+            </a:r>
+          </a:p>
+        </p:txBody>
+      </p:sp>
+      <p:sp>
+        <p:nvSpPr>
+          <p:cNvPr id="5" name="Rectangle 4"/>
+          <p:cNvSpPr/>
+          <p:nvPr/>
+        </p:nvSpPr>
+        <p:spPr>
+          <a:xfrm>
+            <a:off x="251999" y="1143000"/>
+            <a:ext cx="11687697" cy="18288"/>
+          </a:xfrm>
+          <a:prstGeom prst="rect">
+            <a:avLst/>
+          </a:prstGeom>
+          <a:solidFill>
+            <a:srgbClr val="C8CDD3"/>
+          </a:solidFill>
+          <a:ln>
+            <a:noFill/>
+          </a:ln>
+          <a:effectLst/>
+        </p:spPr>
+        <p:style>
+          <a:lnRef idx="1">
+            <a:schemeClr val="accent1"/>
+          </a:lnRef>
+          <a:fillRef idx="3">
+            <a:schemeClr val="accent1"/>
+          </a:fillRef>
+          <a:effectRef idx="2">
+            <a:schemeClr val="accent1"/>
+          </a:effectRef>
+          <a:fontRef idx="minor">
+            <a:schemeClr val="lt1"/>
+          </a:fontRef>
+        </p:style>
+        <p:txBody>
+          <a:bodyPr rtlCol="0" anchor="ctr"/>
+          <a:lstStyle/>
+          <a:p>
+            <a:pPr algn="ctr"/>
+          </a:p>
+        </p:txBody>
+      </p:sp>
+      <p:sp>
+        <p:nvSpPr>
+          <p:cNvPr id="6" name="Rectangle 5"/>
+          <p:cNvSpPr/>
+          <p:nvPr/>
+        </p:nvSpPr>
+        <p:spPr>
+          <a:xfrm>
+            <a:off x="251999" y="1129284"/>
+            <a:ext cx="2011680" cy="45720"/>
+          </a:xfrm>
+          <a:prstGeom prst="rect">
+            <a:avLst/>
+          </a:prstGeom>
+          <a:solidFill>
+            <a:srgbClr val="E09F3E"/>
+          </a:solidFill>
+          <a:ln>
+            <a:noFill/>
+          </a:ln>
+          <a:effectLst/>
+        </p:spPr>
+        <p:style>
+          <a:lnRef idx="1">
+            <a:schemeClr val="accent1"/>
+          </a:lnRef>
+          <a:fillRef idx="3">
+            <a:schemeClr val="accent1"/>
+          </a:fillRef>
+          <a:effectRef idx="2">
+            <a:schemeClr val="accent1"/>
+          </a:effectRef>
+          <a:fontRef idx="minor">
+            <a:schemeClr val="lt1"/>
+          </a:fontRef>
+        </p:style>
+        <p:txBody>
+          <a:bodyPr rtlCol="0" anchor="ctr"/>
+          <a:lstStyle/>
+          <a:p>
+            <a:pPr algn="ctr"/>
+          </a:p>
+        </p:txBody>
+      </p:sp>
+      <p:sp>
+        <p:nvSpPr>
+          <p:cNvPr id="7" name="TextBox 6"/>
+          <p:cNvSpPr txBox="1"/>
+          <p:nvPr/>
+        </p:nvSpPr>
+        <p:spPr>
+          <a:xfrm>
+            <a:off x="389159" y="1874519"/>
+            <a:ext cx="11338560" cy="3383280"/>
+          </a:xfrm>
+          <a:prstGeom prst="rect">
+            <a:avLst/>
+          </a:prstGeom>
+          <a:noFill/>
+        </p:spPr>
+        <p:txBody>
+          <a:bodyPr wrap="square" lIns="0" rIns="0" tIns="0" bIns="0">
+            <a:spAutoFit/>
+          </a:bodyPr>
+          <a:lstStyle>
+            <a:lvl1pPr marL="342900" indent="-342900">
+              <a:spcBef>
+                <a:spcPts val="1600"/>
+              </a:spcBef>
+              <a:buClr>
+                <a:srgbClr val="0B2B4E"/>
+              </a:buClr>
+              <a:buFont typeface="Calibri"/>
+              <a:buChar char="▪"/>
+              <a:defRPr sz="2400" b="0">
+                <a:solidFill>
+                  <a:srgbClr val="0B2B4E"/>
+                </a:solidFill>
+                <a:latin typeface="Calibri"/>
+              </a:defRPr>
+            </a:lvl1pPr>
+            <a:lvl2pPr marL="685800" indent="-228600">
+              <a:spcBef>
+                <a:spcPts val="300"/>
+              </a:spcBef>
+              <a:buClr>
+                <a:srgbClr val="555B66"/>
+              </a:buClr>
+              <a:buFont typeface="Calibri"/>
+              <a:buChar char="–"/>
+              <a:defRPr sz="2200" b="0">
+                <a:solidFill>
+                  <a:srgbClr val="555B66"/>
+                </a:solidFill>
+                <a:latin typeface="Calibri"/>
+              </a:defRPr>
+            </a:lvl2pPr>
+          </a:lstStyle>
+          <a:p>
+            <a:pPr algn="l"/>
+            <a:r>
+              <a:rPr>
+                <a:latin typeface="Calibri"/>
+              </a:rPr>
+              <a:t>Demand is </a:t>
+            </a:r>
+            <a:r>
+              <a:rPr b="1">
+                <a:solidFill>
+                  <a:srgbClr val="0070C0"/>
+                </a:solidFill>
+                <a:latin typeface="Calibri"/>
+              </a:rPr>
+              <a:t>inelastic</a:t>
+            </a:r>
+            <a:r>
+              <a:rPr>
+                <a:latin typeface="Calibri"/>
+              </a:rPr>
+              <a:t>:  |</a:t>
+            </a:r>
+            <a:r>
+              <a:rPr>
+                <a:latin typeface="Calibri"/>
+              </a:rPr>
+              <a:t>E</a:t>
+            </a:r>
+            <a:r>
+              <a:rPr baseline="-25000">
+                <a:latin typeface="Calibri"/>
+              </a:rPr>
+              <a:t>D</a:t>
+            </a:r>
+            <a:r>
+              <a:rPr>
+                <a:latin typeface="Calibri"/>
+              </a:rPr>
+              <a:t>| = 0.2 &lt; 1   →   a higher price raises revenue</a:t>
+            </a:r>
+          </a:p>
+          <a:p>
+            <a:pPr algn="l"/>
+            <a:r>
+              <a:rPr>
+                <a:latin typeface="Calibri"/>
+              </a:rPr>
+              <a:t>Check with the article's ticket counts:</a:t>
+            </a:r>
+          </a:p>
+          <a:p>
+            <a:pPr algn="l" lvl="1"/>
+            <a:r>
+              <a:rPr>
+                <a:latin typeface="Calibri"/>
+              </a:rPr>
+              <a:t>Before:  </a:t>
+            </a:r>
+            <a:r>
+              <a:rPr>
+                <a:latin typeface="Calibri"/>
+              </a:rPr>
+              <a:t>R</a:t>
+            </a:r>
+            <a:r>
+              <a:rPr baseline="-25000">
+                <a:latin typeface="Calibri"/>
+              </a:rPr>
+              <a:t>0</a:t>
+            </a:r>
+            <a:r>
+              <a:rPr>
+                <a:latin typeface="Calibri"/>
+              </a:rPr>
+              <a:t> ≈ 142,000 × $2 = $284,000</a:t>
+            </a:r>
+          </a:p>
+          <a:p>
+            <a:pPr algn="l" lvl="1"/>
+            <a:r>
+              <a:rPr>
+                <a:latin typeface="Calibri"/>
+              </a:rPr>
+              <a:t>After:  </a:t>
+            </a:r>
+            <a:r>
+              <a:rPr>
+                <a:latin typeface="Calibri"/>
+              </a:rPr>
+              <a:t>R</a:t>
+            </a:r>
+            <a:r>
+              <a:rPr baseline="-25000">
+                <a:latin typeface="Calibri"/>
+              </a:rPr>
+              <a:t>1</a:t>
+            </a:r>
+            <a:r>
+              <a:rPr>
+                <a:latin typeface="Calibri"/>
+              </a:rPr>
+              <a:t> ≈ 100,000 × $5 = $500,000</a:t>
+            </a:r>
+          </a:p>
+          <a:p>
+            <a:pPr algn="l"/>
+            <a:r>
+              <a:rPr b="1">
+                <a:solidFill>
+                  <a:srgbClr val="C00000"/>
+                </a:solidFill>
+                <a:latin typeface="Calibri"/>
+              </a:rPr>
+              <a:t>Yes – the article is right:  revenue rose by about 76%</a:t>
+            </a:r>
+          </a:p>
+        </p:txBody>
+      </p:sp>
+      <p:sp>
+        <p:nvSpPr>
+          <p:cNvPr id="8" name="Rectangle 7"/>
+          <p:cNvSpPr/>
+          <p:nvPr/>
+        </p:nvSpPr>
+        <p:spPr>
+          <a:xfrm>
+            <a:off x="0" y="6537960"/>
+            <a:ext cx="12191695" cy="18288"/>
+          </a:xfrm>
+          <a:prstGeom prst="rect">
+            <a:avLst/>
+          </a:prstGeom>
+          <a:solidFill>
+            <a:srgbClr val="C8CDD3"/>
+          </a:solidFill>
+          <a:ln>
+            <a:noFill/>
+          </a:ln>
+          <a:effectLst/>
+        </p:spPr>
+        <p:style>
+          <a:lnRef idx="1">
+            <a:schemeClr val="accent1"/>
+          </a:lnRef>
+          <a:fillRef idx="3">
+            <a:schemeClr val="accent1"/>
+          </a:fillRef>
+          <a:effectRef idx="2">
+            <a:schemeClr val="accent1"/>
+          </a:effectRef>
+          <a:fontRef idx="minor">
+            <a:schemeClr val="lt1"/>
+          </a:fontRef>
+        </p:style>
+        <p:txBody>
+          <a:bodyPr rtlCol="0" anchor="ctr"/>
+          <a:lstStyle/>
+          <a:p>
+            <a:pPr algn="ctr"/>
+          </a:p>
+        </p:txBody>
+      </p:sp>
+      <p:sp>
+        <p:nvSpPr>
+          <p:cNvPr id="9" name="Rectangle 8"/>
+          <p:cNvSpPr/>
+          <p:nvPr/>
+        </p:nvSpPr>
+        <p:spPr>
+          <a:xfrm>
+            <a:off x="251999" y="6524244"/>
+            <a:ext cx="2011680" cy="45720"/>
+          </a:xfrm>
+          <a:prstGeom prst="rect">
+            <a:avLst/>
+          </a:prstGeom>
+          <a:solidFill>
+            <a:srgbClr val="E09F3E"/>
+          </a:solidFill>
+          <a:ln>
+            <a:noFill/>
+          </a:ln>
+          <a:effectLst/>
+        </p:spPr>
+        <p:style>
+          <a:lnRef idx="1">
+            <a:schemeClr val="accent1"/>
+          </a:lnRef>
+          <a:fillRef idx="3">
+            <a:schemeClr val="accent1"/>
+          </a:fillRef>
+          <a:effectRef idx="2">
+            <a:schemeClr val="accent1"/>
+          </a:effectRef>
+          <a:fontRef idx="minor">
+            <a:schemeClr val="lt1"/>
+          </a:fontRef>
+        </p:style>
+        <p:txBody>
+          <a:bodyPr rtlCol="0" anchor="ctr"/>
+          <a:lstStyle/>
+          <a:p>
+            <a:pPr algn="ctr"/>
+          </a:p>
+        </p:txBody>
+      </p:sp>
+      <p:sp>
+        <p:nvSpPr>
+          <p:cNvPr id="10" name="TextBox 9"/>
+          <p:cNvSpPr txBox="1"/>
+          <p:nvPr/>
+        </p:nvSpPr>
+        <p:spPr>
+          <a:xfrm>
+            <a:off x="251999" y="6583680"/>
+            <a:ext cx="10058400" cy="292608"/>
+          </a:xfrm>
+          <a:prstGeom prst="rect">
+            <a:avLst/>
+          </a:prstGeom>
+          <a:noFill/>
+        </p:spPr>
+        <p:txBody>
+          <a:bodyPr wrap="square" lIns="0" rIns="0" tIns="0" bIns="0">
+            <a:spAutoFit/>
+          </a:bodyPr>
+          <a:lstStyle/>
+          <a:p>
+            <a:pPr algn="l"/>
+            <a:r>
+              <a:rPr sz="1200" b="0" i="0" u="none">
+                <a:solidFill>
+                  <a:srgbClr val="555B66"/>
+                </a:solidFill>
+                <a:latin typeface="Calibri"/>
+              </a:rPr>
+              <a:t>Management 405  ·  Demand Analysis</a:t>
+            </a:r>
+          </a:p>
+        </p:txBody>
+      </p:sp>
+      <p:sp>
+        <p:nvSpPr>
+          <p:cNvPr id="11" name="TextBox 10"/>
+          <p:cNvSpPr txBox="1"/>
+          <p:nvPr/>
+        </p:nvSpPr>
+        <p:spPr>
+          <a:xfrm>
+            <a:off x="11475720" y="6583680"/>
+            <a:ext cx="502920" cy="292608"/>
+          </a:xfrm>
+          <a:prstGeom prst="rect">
+            <a:avLst/>
+          </a:prstGeom>
+          <a:noFill/>
+        </p:spPr>
+        <p:txBody>
+          <a:bodyPr wrap="none" lIns="0" rIns="0" tIns="0" bIns="0">
+            <a:spAutoFit/>
+          </a:bodyPr>
+          <a:lstStyle/>
+          <a:p>
+            <a:pPr algn="r"/>
+            <a:fld id="{30F67572-56A1-533B-9B3B-08B9F7B2B9A8}" type="slidenum">
+              <a:rPr lang="en-US" sz="1200" dirty="0">
+                <a:solidFill>
+                  <a:srgbClr val="555B66"/>
+                </a:solidFill>
+                <a:latin typeface="Calibri"/>
+              </a:rPr>
+              <a:t>6</a:t>
+            </a:fld>
+          </a:p>
+        </p:txBody>
+      </p:sp>
+    </p:spTree>
+  </p:cSld>
+  <p:clrMapOvr>
+    <a:masterClrMapping/>
+  </p:clrMapOvr>
 </p:sld>
 </file>
 

</xml_diff>